<commit_message>
docs: 更新 slot_classifier_share.pptx 至 v2.0（Claude Code 串聯版）
封面：v1.0 → v2.0，副標題改為 Claude Code 串聯流程

第2張 工具目的：
  03 整合Figma/Fileserver → Claude Code 串聯完整流程

第3張 輸出：
  figma_export/ → review.html（瀏覽器審核頁）
  Fileserver 備份 → needs_review/（中低信心副本）

第4張 整體流程：
  步驟02：run_classifier.bat → classify_with_roi_confirm.sh
  步驟03：Claude Skill → 人工審核修正（localhost:8765）
  步驟04：備份/Figma → Claude Skill 報告（slot-report）

第5張 TOC → 更新為新流程五段落
第6張 環境架設 → 新增 Claude Code CLI 安裝步驟
第7張 主程式 → ROI 確認流程 + needs_review 輸出結構
第8張 人工審核修正（信心等級說明 + 操作步驟）
第9張 Claude Skill 競品報告（三大段落說明 + CCMS 同步）
第10張 GitHub 取得最新版本（分支說明 + 關鍵檔案）
第11張 GitHub 專案結構 → 更新為 pipeline.py/scorers/CLAUDE.md 等新檔
第12張 已完成項目標示 ✅，待優化項目標示 🔄

Co-Authored-By: Claude Sonnet 4.5 <noreply@anthropic.com>
</commit_message>
<xml_diff>
--- a/docs/slot_classifier_share.pptx
+++ b/docs/slot_classifier_share.pptx
@@ -16496,7 +16496,7 @@
                 <a:cs typeface="Calibri"/>
                 <a:sym typeface="Calibri"/>
               </a:rPr>
-              <a:t>自動截圖分類  ·  競品報告生成  ·  Figma Board  ·  Fileserver 備份</a:t>
+              <a:t>Claude Code 串聯  ·  自動截圖分類  ·  ROI 人工確認  ·  審核修正  ·  競品報告生成</a:t>
             </a:r>
             <a:endParaRPr sz="1100"/>
           </a:p>
@@ -16649,7 +16649,7 @@
                 <a:cs typeface="Calibri"/>
                 <a:sym typeface="Calibri"/>
               </a:rPr>
-              <a:t>v 1.0</a:t>
+              <a:t>v 2.0</a:t>
             </a:r>
             <a:endParaRPr sz="1100"/>
           </a:p>
@@ -16877,7 +16877,7 @@
                 <a:cs typeface="Calibri"/>
                 <a:sym typeface="Calibri"/>
               </a:rPr>
-              <a:t>備份至 Fileserver</a:t>
+              <a:t>GitHub 取得最新版本</a:t>
             </a:r>
             <a:endParaRPr sz="1100"/>
           </a:p>
@@ -16927,7 +16927,7 @@
                 <a:cs typeface="Calibri"/>
                 <a:sym typeface="Calibri"/>
               </a:rPr>
-              <a:t>Archive to Fileserver</a:t>
+              <a:t>Getting Latest Version from GitHub</a:t>
             </a:r>
             <a:endParaRPr sz="1100"/>
           </a:p>
@@ -17034,7 +17034,7 @@
                 <a:cs typeface="Calibri"/>
                 <a:sym typeface="Calibri"/>
               </a:rPr>
-              <a:t>4.5  備份</a:t>
+              <a:t>4.5  GitHub</a:t>
             </a:r>
             <a:endParaRPr sz="1100"/>
           </a:p>
@@ -17084,7 +17084,7 @@
                 <a:cs typeface="Calibri"/>
                 <a:sym typeface="Calibri"/>
               </a:rPr>
-              <a:t>執行備份腳本：</a:t>
+              <a:t>更新至最新版：</a:t>
             </a:r>
             <a:endParaRPr sz="1100"/>
           </a:p>
@@ -17191,7 +17191,9 @@
                 <a:cs typeface="Consolas"/>
                 <a:sym typeface="Consolas"/>
               </a:rPr>
-              <a:t>.\archive_to_fileserver.ps1</a:t>
+              <a:t>git fetch origin
+git checkout perf/cpu-optimize-ocr
+git pull</a:t>
             </a:r>
             <a:endParaRPr sz="1100"/>
           </a:p>
@@ -17241,7 +17243,7 @@
                 <a:cs typeface="Calibri"/>
                 <a:sym typeface="Calibri"/>
               </a:rPr>
-              <a:t>備份目標結構  ─  AI_survey / GameName /</a:t>
+              <a:t>主要分支說明</a:t>
             </a:r>
             <a:endParaRPr sz="1100"/>
           </a:p>
@@ -17344,7 +17346,7 @@
                 <a:cs typeface="Calibri"/>
                 <a:sym typeface="Calibri"/>
               </a:rPr>
-              <a:t>01_report</a:t>
+              <a:t>perf/cpu-optimize-ocr</a:t>
             </a:r>
             <a:endParaRPr sz="1100"/>
           </a:p>
@@ -17445,7 +17447,7 @@
                 <a:cs typeface="Calibri"/>
                 <a:sym typeface="Calibri"/>
               </a:rPr>
-              <a:t>HTML 競品分析報告 + assets</a:t>
+              <a:t>目前最新穩定版（CPU 優化 + ROI 確認 + 審核修正）</a:t>
             </a:r>
             <a:endParaRPr sz="1100"/>
           </a:p>
@@ -17548,7 +17550,7 @@
                 <a:cs typeface="Calibri"/>
                 <a:sym typeface="Calibri"/>
               </a:rPr>
-              <a:t>02_classified_images</a:t>
+              <a:t>main</a:t>
             </a:r>
             <a:endParaRPr sz="1100"/>
           </a:p>
@@ -17649,7 +17651,7 @@
                 <a:cs typeface="Calibri"/>
                 <a:sym typeface="Calibri"/>
               </a:rPr>
-              <a:t>分類截圖（Basegame / Feature 等）</a:t>
+              <a:t>穩定發布版（合併後更新）</a:t>
             </a:r>
             <a:endParaRPr sz="1100"/>
           </a:p>
@@ -17752,7 +17754,7 @@
                 <a:cs typeface="Calibri"/>
                 <a:sym typeface="Calibri"/>
               </a:rPr>
-              <a:t>03_figma</a:t>
+              <a:t>關鍵檔案</a:t>
             </a:r>
             <a:endParaRPr sz="1100"/>
           </a:p>
@@ -17853,7 +17855,9 @@
                 <a:cs typeface="Calibri"/>
                 <a:sym typeface="Calibri"/>
               </a:rPr>
-              <a:t>Figma 匯入包（manifest + images）</a:t>
+              <a:t>CLAUDE.md — Claude 工作規則
+app/pipeline.py + scorers/ — 核心分類邏輯
+classify_with_roi_confirm.sh — 主入口腳本</a:t>
             </a:r>
             <a:endParaRPr sz="1100"/>
           </a:p>
@@ -17956,7 +17960,7 @@
                 <a:cs typeface="Calibri"/>
                 <a:sym typeface="Calibri"/>
               </a:rPr>
-              <a:t>04_logs</a:t>
+              <a:t>重要注意</a:t>
             </a:r>
             <a:endParaRPr sz="1100"/>
           </a:p>
@@ -18057,7 +18061,7 @@
                 <a:cs typeface="Calibri"/>
                 <a:sym typeface="Calibri"/>
               </a:rPr>
-              <a:t>執行紀錄與低信心值截圖</a:t>
+              <a:t>Windows 使用者需透過 Git Bash 或 WSL 執行 .sh 腳本</a:t>
             </a:r>
             <a:endParaRPr sz="1100"/>
           </a:p>
@@ -18160,7 +18164,7 @@
                 <a:cs typeface="Calibri"/>
                 <a:sym typeface="Calibri"/>
               </a:rPr>
-              <a:t>video</a:t>
+              <a:t>repo URL</a:t>
             </a:r>
             <a:endParaRPr sz="1100"/>
           </a:p>
@@ -18261,7 +18265,7 @@
                 <a:cs typeface="Calibri"/>
                 <a:sym typeface="Calibri"/>
               </a:rPr>
-              <a:t>原始影片（選擇性備份）</a:t>
+              <a:t>https://github.com/Ashley860511/slot-classifier</a:t>
             </a:r>
             <a:endParaRPr sz="1100"/>
           </a:p>
@@ -18362,7 +18366,7 @@
                 <a:cs typeface="Calibri"/>
                 <a:sym typeface="Calibri"/>
               </a:rPr>
-              <a:t>⚠  low_score 截圖請先人工確認分類正確性，再決定備份至 Help 或 Other；HTML report 與 assets 保持原始資料夾結構以避免路徑失效</a:t>
+              <a:t>⚠  請確保 .venv 已建立且 requirements.txt 安裝完成，才能正確執行分類</a:t>
             </a:r>
             <a:endParaRPr sz="1100"/>
           </a:p>
@@ -18414,7 +18418,7 @@
                 <a:cs typeface="Calibri"/>
                 <a:sym typeface="Calibri"/>
               </a:rPr>
-              <a:t>備份位址：</a:t>
+              <a:t>文件位置：</a:t>
             </a:r>
             <a:endParaRPr sz="800">
               <a:solidFill>
@@ -18446,7 +18450,7 @@
                 <a:cs typeface="Calibri"/>
                 <a:sym typeface="Calibri"/>
               </a:rPr>
-              <a:t>\\192.168.123.5\jl商用遊戲機事務處\JLRD01研發一部\JLRD03美術設計\IGaming\0_Common\AI_survey</a:t>
+              <a:t>docs/ 資料夾內有 slot_classifier_usage_guide.html 與 python_environment_install_guide.html</a:t>
             </a:r>
             <a:endParaRPr sz="800">
               <a:solidFill>
@@ -19091,7 +19095,7 @@
                 <a:cs typeface="Calibri"/>
                 <a:sym typeface="Calibri"/>
               </a:rPr>
-              <a:t>app/               主程式：分類器、OCR、ROI 偵測、Symbol Table 提取</a:t>
+              <a:t>app/pipeline.py + scorers/    核心分類流程與各類別評分模組</a:t>
             </a:r>
             <a:endParaRPr sz="1100"/>
           </a:p>
@@ -19192,7 +19196,7 @@
                 <a:cs typeface="Calibri"/>
                 <a:sym typeface="Calibri"/>
               </a:rPr>
-              <a:t>claude/            slot-report Skill 安裝指南與完整 SKILL.md 範本</a:t>
+              <a:t>app/generate_review_page.py   生成 review.html 審核頁</a:t>
             </a:r>
             <a:endParaRPr sz="1100"/>
           </a:p>
@@ -19293,7 +19297,7 @@
                 <a:cs typeface="Calibri"/>
                 <a:sym typeface="Calibri"/>
               </a:rPr>
-              <a:t>figma_tools/       Figma plugin（manifest + code.js）與 export 腳本</a:t>
+              <a:t>review_server.py  /  apply_corrections.py   本機審核 Server + 修正套用</a:t>
             </a:r>
             <a:endParaRPr sz="1100"/>
           </a:p>
@@ -19394,7 +19398,7 @@
                 <a:cs typeface="Calibri"/>
                 <a:sym typeface="Calibri"/>
               </a:rPr>
-              <a:t>docs/              HTML 技術文件（使用教學、環境安裝說明）</a:t>
+              <a:t>classify_with_roi_confirm.sh   主入口腳本（ROI 確認 → 分類 → 審核 → Server）</a:t>
             </a:r>
             <a:endParaRPr sz="1100"/>
           </a:p>
@@ -19495,7 +19499,8 @@
                 <a:cs typeface="Calibri"/>
                 <a:sym typeface="Calibri"/>
               </a:rPr>
-              <a:t>setup_venv.ps1  /  run_classifier.ps1  /  run_figma_export.ps1  /  archive_to_fileserver.ps1</a:t>
+              <a:t>CLAUDE.md   Claude Code 工作規則（啟動後自動載入）
+docs/   HTML 技術文件（使用教學、環境安裝說明）</a:t>
             </a:r>
             <a:endParaRPr sz="1100"/>
           </a:p>
@@ -20028,7 +20033,7 @@
                 <a:cs typeface="Calibri"/>
                 <a:sym typeface="Calibri"/>
               </a:rPr>
-              <a:t>Feature 細分偵測</a:t>
+              <a:t>✅ Feature 細分偵測（已完成）</a:t>
             </a:r>
             <a:endParaRPr sz="1100"/>
           </a:p>
@@ -20078,7 +20083,7 @@
                 <a:cs typeface="Calibri"/>
                 <a:sym typeface="Calibri"/>
               </a:rPr>
-              <a:t>偵測 Feature active / subtype，自動辨識 Free Spins、Bonus、Jackpot 等子類型，提升分類粒度。</a:t>
+              <a:t>feature_subtype 已實作，支援 FreeSpins / PickBonus / Jackpot / Multiplier 等子類型自動辨識。</a:t>
             </a:r>
             <a:endParaRPr sz="1100"/>
           </a:p>
@@ -20333,7 +20338,7 @@
                 <a:cs typeface="Calibri"/>
                 <a:sym typeface="Calibri"/>
               </a:rPr>
-              <a:t>大型 Bonus Game 支援</a:t>
+              <a:t>🔄 大型 Bonus Game 支援（待優化）</a:t>
             </a:r>
             <a:endParaRPr sz="1100"/>
           </a:p>
@@ -20638,7 +20643,7 @@
                 <a:cs typeface="Calibri"/>
                 <a:sym typeface="Calibri"/>
               </a:rPr>
-              <a:t>OCR 辨識率提升</a:t>
+              <a:t>✅ OCR 效能優化（已完成）</a:t>
             </a:r>
             <a:endParaRPr sz="1100"/>
           </a:p>
@@ -20688,7 +20693,7 @@
                 <a:cs typeface="Calibri"/>
                 <a:sym typeface="Calibri"/>
               </a:rPr>
-              <a:t>改善中英文混合介面的文字辨識率，優化遊戲標題、數值與符號文字的提取品質。</a:t>
+              <a:t>cpu_threads=2 + OCR 輸入限 480px + 停用 angle classifier。4 分鐘影片約 5～10 分鐘完成（CPU-only）。</a:t>
             </a:r>
             <a:endParaRPr sz="1100"/>
           </a:p>
@@ -20943,7 +20948,7 @@
                 <a:cs typeface="Calibri"/>
                 <a:sym typeface="Calibri"/>
               </a:rPr>
-              <a:t>資料管理強化</a:t>
+              <a:t>🔄 Symbol 裁切整合（待優化）</a:t>
             </a:r>
             <a:endParaRPr sz="1100"/>
           </a:p>
@@ -20993,7 +20998,7 @@
                 <a:cs typeface="Calibri"/>
                 <a:sym typeface="Calibri"/>
               </a:rPr>
-              <a:t>建立競品遊戲資料庫索引、Fileserver manifest、版本控管，以及定期自動比對與更新機制。</a:t>
+              <a:t>從 Help / Paytable 截圖自動裁切 Symbol 圖示，整合至競品報告的符號賠率表段落。</a:t>
             </a:r>
             <a:endParaRPr sz="1100"/>
           </a:p>
@@ -21983,7 +21988,7 @@
                 <a:cs typeface="Calibri"/>
                 <a:sym typeface="Calibri"/>
               </a:rPr>
-              <a:t>整合 Figma 與 Fileserver</a:t>
+              <a:t>Claude Code 串聯完整流程</a:t>
             </a:r>
             <a:endParaRPr sz="1100"/>
           </a:p>
@@ -22033,7 +22038,7 @@
                 <a:cs typeface="Calibri"/>
                 <a:sym typeface="Calibri"/>
               </a:rPr>
-              <a:t>一鍵匯出 Figma Research Board，並自動備份至公司 Fileserver（AI_survey 資料夾），建立可查詢的競品資料庫。</a:t>
+              <a:t>在專案根目錄執行 claude，用對話觸發完整流程：ROI 確認 → 截圖分類 → review.html 審核 → 競品報告，全程不需手動執行腳本。</a:t>
             </a:r>
             <a:endParaRPr sz="1100"/>
           </a:p>
@@ -23881,7 +23886,7 @@
                 <a:cs typeface="Calibri"/>
                 <a:sym typeface="Calibri"/>
               </a:rPr>
-              <a:t>figma_export/</a:t>
+              <a:t>review.html</a:t>
             </a:r>
             <a:endParaRPr sz="1100"/>
           </a:p>
@@ -23931,7 +23936,7 @@
                 <a:cs typeface="Calibri"/>
                 <a:sym typeface="Calibri"/>
               </a:rPr>
-              <a:t>Figma Research Board 匯入包</a:t>
+              <a:t>瀏覽器審核頁，支援改分類與排除</a:t>
             </a:r>
             <a:endParaRPr sz="1100"/>
           </a:p>
@@ -24084,7 +24089,7 @@
                 <a:cs typeface="Calibri"/>
                 <a:sym typeface="Calibri"/>
               </a:rPr>
-              <a:t>Fileserver 備份</a:t>
+              <a:t>needs_review/</a:t>
             </a:r>
             <a:endParaRPr sz="1100"/>
           </a:p>
@@ -24134,7 +24139,7 @@
                 <a:cs typeface="Calibri"/>
                 <a:sym typeface="Calibri"/>
               </a:rPr>
-              <a:t>AI_survey 資料夾標準備份</a:t>
+              <a:t>中低信心截圖副本，供人工複審</a:t>
             </a:r>
             <a:endParaRPr sz="1100"/>
           </a:p>
@@ -25169,7 +25174,7 @@
                 <a:cs typeface="Calibri"/>
                 <a:sym typeface="Calibri"/>
               </a:rPr>
-              <a:t>主程式截圖分類</a:t>
+              <a:t>Claude Code 串聯分類</a:t>
             </a:r>
             <a:endParaRPr sz="1100"/>
           </a:p>
@@ -25744,7 +25749,7 @@
                 <a:cs typeface="Calibri"/>
                 <a:sym typeface="Calibri"/>
               </a:rPr>
-              <a:t>Claude Skill 生成報告</a:t>
+              <a:t>人工審核修正</a:t>
             </a:r>
             <a:endParaRPr sz="1100"/>
           </a:p>
@@ -25810,6 +25815,561 @@
         <p:spPr>
           <a:xfrm>
             <a:off x="4976775" y="1611630"/>
+            <a:ext cx="1543452" cy="288036"/>
+          </a:xfrm>
+          <a:prstGeom prst="rect">
+            <a:avLst/>
+          </a:prstGeom>
+          <a:noFill/>
+          <a:ln>
+            <a:noFill/>
+          </a:ln>
+        </p:spPr>
+        <p:txBody>
+          <a:bodyPr anchorCtr="0" anchor="t" bIns="37500" lIns="37500" spcFirstLastPara="1" rIns="37500" wrap="square" tIns="37500">
+            <a:spAutoFit/>
+          </a:bodyPr>
+          <a:lstStyle/>
+          <a:p>
+            <a:pPr indent="0" lvl="0" marL="0" marR="0" rtl="0" algn="l">
+              <a:spcBef>
+                <a:spcPts val="0"/>
+              </a:spcBef>
+              <a:spcAft>
+                <a:spcPts val="0"/>
+              </a:spcAft>
+              <a:buNone/>
+            </a:pPr>
+            <a:r>
+              <a:rPr b="0" i="0" lang="zh-TW" sz="800">
+                <a:solidFill>
+                  <a:srgbClr val="2D2D2D"/>
+                </a:solidFill>
+                <a:latin typeface="Calibri"/>
+                <a:ea typeface="Calibri"/>
+                <a:cs typeface="Calibri"/>
+                <a:sym typeface="Calibri"/>
+              </a:rPr>
+              <a:t>http://localhost:8765</a:t>
+            </a:r>
+            <a:endParaRPr sz="1100"/>
+          </a:p>
+        </p:txBody>
+      </p:sp>
+      <p:sp>
+        <p:nvSpPr>
+          <p:cNvPr id="245" name="Google Shape;245;p28"/>
+          <p:cNvSpPr txBox="1"/>
+          <p:nvPr/>
+        </p:nvSpPr>
+        <p:spPr>
+          <a:xfrm>
+            <a:off x="4860159" y="2057400"/>
+            <a:ext cx="41159" cy="150876"/>
+          </a:xfrm>
+          <a:prstGeom prst="rect">
+            <a:avLst/>
+          </a:prstGeom>
+          <a:solidFill>
+            <a:srgbClr val="7C3AED"/>
+          </a:solidFill>
+          <a:ln>
+            <a:noFill/>
+          </a:ln>
+        </p:spPr>
+        <p:txBody>
+          <a:bodyPr anchorCtr="0" anchor="t" bIns="34275" lIns="68575" spcFirstLastPara="1" rIns="68575" wrap="square" tIns="34275">
+            <a:spAutoFit/>
+          </a:bodyPr>
+          <a:lstStyle/>
+          <a:p>
+            <a:pPr indent="0" lvl="0" marL="0" marR="0" rtl="0" algn="l">
+              <a:spcBef>
+                <a:spcPts val="0"/>
+              </a:spcBef>
+              <a:spcAft>
+                <a:spcPts val="0"/>
+              </a:spcAft>
+              <a:buNone/>
+            </a:pPr>
+            <a:r>
+              <a:t/>
+            </a:r>
+            <a:endParaRPr sz="1400">
+              <a:solidFill>
+                <a:schemeClr val="dk1"/>
+              </a:solidFill>
+              <a:latin typeface="Calibri"/>
+              <a:ea typeface="Calibri"/>
+              <a:cs typeface="Calibri"/>
+              <a:sym typeface="Calibri"/>
+            </a:endParaRPr>
+          </a:p>
+        </p:txBody>
+      </p:sp>
+      <p:sp>
+        <p:nvSpPr>
+          <p:cNvPr id="246" name="Google Shape;246;p28"/>
+          <p:cNvSpPr txBox="1"/>
+          <p:nvPr/>
+        </p:nvSpPr>
+        <p:spPr>
+          <a:xfrm>
+            <a:off x="4976775" y="1988820"/>
+            <a:ext cx="1543452" cy="288036"/>
+          </a:xfrm>
+          <a:prstGeom prst="rect">
+            <a:avLst/>
+          </a:prstGeom>
+          <a:noFill/>
+          <a:ln>
+            <a:noFill/>
+          </a:ln>
+        </p:spPr>
+        <p:txBody>
+          <a:bodyPr anchorCtr="0" anchor="t" bIns="37500" lIns="37500" spcFirstLastPara="1" rIns="37500" wrap="square" tIns="37500">
+            <a:spAutoFit/>
+          </a:bodyPr>
+          <a:lstStyle/>
+          <a:p>
+            <a:pPr indent="0" lvl="0" marL="0" marR="0" rtl="0" algn="l">
+              <a:spcBef>
+                <a:spcPts val="0"/>
+              </a:spcBef>
+              <a:spcAft>
+                <a:spcPts val="0"/>
+              </a:spcAft>
+              <a:buNone/>
+            </a:pPr>
+            <a:r>
+              <a:rPr b="0" i="0" lang="zh-TW" sz="800">
+                <a:solidFill>
+                  <a:srgbClr val="2D2D2D"/>
+                </a:solidFill>
+                <a:latin typeface="Calibri"/>
+                <a:ea typeface="Calibri"/>
+                <a:cs typeface="Calibri"/>
+                <a:sym typeface="Calibri"/>
+              </a:rPr>
+              <a:t>review.html 審核頁</a:t>
+            </a:r>
+            <a:endParaRPr sz="1100"/>
+          </a:p>
+        </p:txBody>
+      </p:sp>
+      <p:sp>
+        <p:nvSpPr>
+          <p:cNvPr id="247" name="Google Shape;247;p28"/>
+          <p:cNvSpPr txBox="1"/>
+          <p:nvPr/>
+        </p:nvSpPr>
+        <p:spPr>
+          <a:xfrm>
+            <a:off x="4860159" y="2434590"/>
+            <a:ext cx="41159" cy="150876"/>
+          </a:xfrm>
+          <a:prstGeom prst="rect">
+            <a:avLst/>
+          </a:prstGeom>
+          <a:solidFill>
+            <a:srgbClr val="7C3AED"/>
+          </a:solidFill>
+          <a:ln>
+            <a:noFill/>
+          </a:ln>
+        </p:spPr>
+        <p:txBody>
+          <a:bodyPr anchorCtr="0" anchor="t" bIns="34275" lIns="68575" spcFirstLastPara="1" rIns="68575" wrap="square" tIns="34275">
+            <a:spAutoFit/>
+          </a:bodyPr>
+          <a:lstStyle/>
+          <a:p>
+            <a:pPr indent="0" lvl="0" marL="0" marR="0" rtl="0" algn="l">
+              <a:spcBef>
+                <a:spcPts val="0"/>
+              </a:spcBef>
+              <a:spcAft>
+                <a:spcPts val="0"/>
+              </a:spcAft>
+              <a:buNone/>
+            </a:pPr>
+            <a:r>
+              <a:t/>
+            </a:r>
+            <a:endParaRPr sz="1400">
+              <a:solidFill>
+                <a:schemeClr val="dk1"/>
+              </a:solidFill>
+              <a:latin typeface="Calibri"/>
+              <a:ea typeface="Calibri"/>
+              <a:cs typeface="Calibri"/>
+              <a:sym typeface="Calibri"/>
+            </a:endParaRPr>
+          </a:p>
+        </p:txBody>
+      </p:sp>
+      <p:sp>
+        <p:nvSpPr>
+          <p:cNvPr id="248" name="Google Shape;248;p28"/>
+          <p:cNvSpPr txBox="1"/>
+          <p:nvPr/>
+        </p:nvSpPr>
+        <p:spPr>
+          <a:xfrm>
+            <a:off x="4976775" y="2366010"/>
+            <a:ext cx="1543452" cy="288036"/>
+          </a:xfrm>
+          <a:prstGeom prst="rect">
+            <a:avLst/>
+          </a:prstGeom>
+          <a:noFill/>
+          <a:ln>
+            <a:noFill/>
+          </a:ln>
+        </p:spPr>
+        <p:txBody>
+          <a:bodyPr anchorCtr="0" anchor="t" bIns="37500" lIns="37500" spcFirstLastPara="1" rIns="37500" wrap="square" tIns="37500">
+            <a:spAutoFit/>
+          </a:bodyPr>
+          <a:lstStyle/>
+          <a:p>
+            <a:pPr indent="0" lvl="0" marL="0" marR="0" rtl="0" algn="l">
+              <a:spcBef>
+                <a:spcPts val="0"/>
+              </a:spcBef>
+              <a:spcAft>
+                <a:spcPts val="0"/>
+              </a:spcAft>
+              <a:buNone/>
+            </a:pPr>
+            <a:r>
+              <a:rPr b="0" i="0" lang="zh-TW" sz="800">
+                <a:solidFill>
+                  <a:srgbClr val="2D2D2D"/>
+                </a:solidFill>
+                <a:latin typeface="Calibri"/>
+                <a:ea typeface="Calibri"/>
+                <a:cs typeface="Calibri"/>
+                <a:sym typeface="Calibri"/>
+              </a:rPr>
+              <a:t>改分類 / 排除 / 套用修正</a:t>
+            </a:r>
+            <a:endParaRPr sz="1100"/>
+          </a:p>
+        </p:txBody>
+      </p:sp>
+      <p:sp>
+        <p:nvSpPr>
+          <p:cNvPr id="249" name="Google Shape;249;p28"/>
+          <p:cNvSpPr txBox="1"/>
+          <p:nvPr/>
+        </p:nvSpPr>
+        <p:spPr>
+          <a:xfrm>
+            <a:off x="6650562" y="2606040"/>
+            <a:ext cx="150915" cy="342900"/>
+          </a:xfrm>
+          <a:prstGeom prst="rect">
+            <a:avLst/>
+          </a:prstGeom>
+          <a:noFill/>
+          <a:ln>
+            <a:noFill/>
+          </a:ln>
+        </p:spPr>
+        <p:txBody>
+          <a:bodyPr anchorCtr="0" anchor="ctr" bIns="37500" lIns="37500" spcFirstLastPara="1" rIns="37500" wrap="square" tIns="37500">
+            <a:spAutoFit/>
+          </a:bodyPr>
+          <a:lstStyle/>
+          <a:p>
+            <a:pPr indent="0" lvl="0" marL="0" marR="0" rtl="0" algn="ctr">
+              <a:spcBef>
+                <a:spcPts val="0"/>
+              </a:spcBef>
+              <a:spcAft>
+                <a:spcPts val="0"/>
+              </a:spcAft>
+              <a:buNone/>
+            </a:pPr>
+            <a:r>
+              <a:rPr b="1" i="0" lang="zh-TW" sz="1100">
+                <a:solidFill>
+                  <a:srgbClr val="FCA311"/>
+                </a:solidFill>
+                <a:latin typeface="Calibri"/>
+                <a:ea typeface="Calibri"/>
+                <a:cs typeface="Calibri"/>
+                <a:sym typeface="Calibri"/>
+              </a:rPr>
+              <a:t>▶</a:t>
+            </a:r>
+            <a:endParaRPr sz="1100"/>
+          </a:p>
+        </p:txBody>
+      </p:sp>
+      <p:sp>
+        <p:nvSpPr>
+          <p:cNvPr id="250" name="Google Shape;250;p28"/>
+          <p:cNvSpPr txBox="1"/>
+          <p:nvPr/>
+        </p:nvSpPr>
+        <p:spPr>
+          <a:xfrm>
+            <a:off x="6815198" y="1028700"/>
+            <a:ext cx="1955039" cy="2606040"/>
+          </a:xfrm>
+          <a:prstGeom prst="rect">
+            <a:avLst/>
+          </a:prstGeom>
+          <a:solidFill>
+            <a:srgbClr val="F4F5F7"/>
+          </a:solidFill>
+          <a:ln>
+            <a:noFill/>
+          </a:ln>
+        </p:spPr>
+        <p:txBody>
+          <a:bodyPr anchorCtr="0" anchor="t" bIns="34275" lIns="68575" spcFirstLastPara="1" rIns="68575" wrap="square" tIns="34275">
+            <a:spAutoFit/>
+          </a:bodyPr>
+          <a:lstStyle/>
+          <a:p>
+            <a:pPr indent="0" lvl="0" marL="0" marR="0" rtl="0" algn="l">
+              <a:spcBef>
+                <a:spcPts val="0"/>
+              </a:spcBef>
+              <a:spcAft>
+                <a:spcPts val="0"/>
+              </a:spcAft>
+              <a:buNone/>
+            </a:pPr>
+            <a:r>
+              <a:t/>
+            </a:r>
+            <a:endParaRPr sz="1400">
+              <a:solidFill>
+                <a:schemeClr val="dk1"/>
+              </a:solidFill>
+              <a:latin typeface="Calibri"/>
+              <a:ea typeface="Calibri"/>
+              <a:cs typeface="Calibri"/>
+              <a:sym typeface="Calibri"/>
+            </a:endParaRPr>
+          </a:p>
+        </p:txBody>
+      </p:sp>
+      <p:sp>
+        <p:nvSpPr>
+          <p:cNvPr id="251" name="Google Shape;251;p28"/>
+          <p:cNvSpPr txBox="1"/>
+          <p:nvPr/>
+        </p:nvSpPr>
+        <p:spPr>
+          <a:xfrm>
+            <a:off x="6815198" y="1028700"/>
+            <a:ext cx="1955039" cy="425196"/>
+          </a:xfrm>
+          <a:prstGeom prst="rect">
+            <a:avLst/>
+          </a:prstGeom>
+          <a:solidFill>
+            <a:srgbClr val="E86A17"/>
+          </a:solidFill>
+          <a:ln>
+            <a:noFill/>
+          </a:ln>
+        </p:spPr>
+        <p:txBody>
+          <a:bodyPr anchorCtr="0" anchor="t" bIns="34275" lIns="68575" spcFirstLastPara="1" rIns="68575" wrap="square" tIns="34275">
+            <a:spAutoFit/>
+          </a:bodyPr>
+          <a:lstStyle/>
+          <a:p>
+            <a:pPr indent="0" lvl="0" marL="0" marR="0" rtl="0" algn="l">
+              <a:spcBef>
+                <a:spcPts val="0"/>
+              </a:spcBef>
+              <a:spcAft>
+                <a:spcPts val="0"/>
+              </a:spcAft>
+              <a:buNone/>
+            </a:pPr>
+            <a:r>
+              <a:t/>
+            </a:r>
+            <a:endParaRPr sz="1400">
+              <a:solidFill>
+                <a:schemeClr val="dk1"/>
+              </a:solidFill>
+              <a:latin typeface="Calibri"/>
+              <a:ea typeface="Calibri"/>
+              <a:cs typeface="Calibri"/>
+              <a:sym typeface="Calibri"/>
+            </a:endParaRPr>
+          </a:p>
+        </p:txBody>
+      </p:sp>
+      <p:sp>
+        <p:nvSpPr>
+          <p:cNvPr id="252" name="Google Shape;252;p28"/>
+          <p:cNvSpPr txBox="1"/>
+          <p:nvPr/>
+        </p:nvSpPr>
+        <p:spPr>
+          <a:xfrm>
+            <a:off x="6918095" y="1097280"/>
+            <a:ext cx="329270" cy="308610"/>
+          </a:xfrm>
+          <a:prstGeom prst="rect">
+            <a:avLst/>
+          </a:prstGeom>
+          <a:noFill/>
+          <a:ln>
+            <a:noFill/>
+          </a:ln>
+        </p:spPr>
+        <p:txBody>
+          <a:bodyPr anchorCtr="0" anchor="t" bIns="37500" lIns="37500" spcFirstLastPara="1" rIns="37500" wrap="square" tIns="37500">
+            <a:spAutoFit/>
+          </a:bodyPr>
+          <a:lstStyle/>
+          <a:p>
+            <a:pPr indent="0" lvl="0" marL="0" marR="0" rtl="0" algn="l">
+              <a:spcBef>
+                <a:spcPts val="0"/>
+              </a:spcBef>
+              <a:spcAft>
+                <a:spcPts val="0"/>
+              </a:spcAft>
+              <a:buNone/>
+            </a:pPr>
+            <a:r>
+              <a:rPr b="1" i="0" lang="zh-TW" sz="1400">
+                <a:solidFill>
+                  <a:srgbClr val="FFFFFF"/>
+                </a:solidFill>
+                <a:latin typeface="Calibri"/>
+                <a:ea typeface="Calibri"/>
+                <a:cs typeface="Calibri"/>
+                <a:sym typeface="Calibri"/>
+              </a:rPr>
+              <a:t>04</a:t>
+            </a:r>
+            <a:endParaRPr sz="1100"/>
+          </a:p>
+        </p:txBody>
+      </p:sp>
+      <p:sp>
+        <p:nvSpPr>
+          <p:cNvPr id="253" name="Google Shape;253;p28"/>
+          <p:cNvSpPr txBox="1"/>
+          <p:nvPr/>
+        </p:nvSpPr>
+        <p:spPr>
+          <a:xfrm>
+            <a:off x="7192486" y="1083564"/>
+            <a:ext cx="1474854" cy="329184"/>
+          </a:xfrm>
+          <a:prstGeom prst="rect">
+            <a:avLst/>
+          </a:prstGeom>
+          <a:noFill/>
+          <a:ln>
+            <a:noFill/>
+          </a:ln>
+        </p:spPr>
+        <p:txBody>
+          <a:bodyPr anchorCtr="0" anchor="t" bIns="37500" lIns="37500" spcFirstLastPara="1" rIns="37500" wrap="square" tIns="37500">
+            <a:spAutoFit/>
+          </a:bodyPr>
+          <a:lstStyle/>
+          <a:p>
+            <a:pPr indent="0" lvl="0" marL="0" marR="0" rtl="0" algn="l">
+              <a:spcBef>
+                <a:spcPts val="0"/>
+              </a:spcBef>
+              <a:spcAft>
+                <a:spcPts val="0"/>
+              </a:spcAft>
+              <a:buNone/>
+            </a:pPr>
+            <a:r>
+              <a:rPr b="1" i="0" lang="zh-TW" sz="900">
+                <a:solidFill>
+                  <a:srgbClr val="FFFFFF"/>
+                </a:solidFill>
+                <a:latin typeface="Calibri"/>
+                <a:ea typeface="Calibri"/>
+                <a:cs typeface="Calibri"/>
+                <a:sym typeface="Calibri"/>
+              </a:rPr>
+              <a:t>Claude Skill 生成報告</a:t>
+            </a:r>
+            <a:endParaRPr sz="1100"/>
+          </a:p>
+        </p:txBody>
+      </p:sp>
+      <p:sp>
+        <p:nvSpPr>
+          <p:cNvPr id="254" name="Google Shape;254;p28"/>
+          <p:cNvSpPr txBox="1"/>
+          <p:nvPr/>
+        </p:nvSpPr>
+        <p:spPr>
+          <a:xfrm>
+            <a:off x="7007272" y="1680210"/>
+            <a:ext cx="41159" cy="150876"/>
+          </a:xfrm>
+          <a:prstGeom prst="rect">
+            <a:avLst/>
+          </a:prstGeom>
+          <a:solidFill>
+            <a:srgbClr val="E86A17"/>
+          </a:solidFill>
+          <a:ln>
+            <a:noFill/>
+          </a:ln>
+        </p:spPr>
+        <p:txBody>
+          <a:bodyPr anchorCtr="0" anchor="t" bIns="34275" lIns="68575" spcFirstLastPara="1" rIns="68575" wrap="square" tIns="34275">
+            <a:spAutoFit/>
+          </a:bodyPr>
+          <a:lstStyle/>
+          <a:p>
+            <a:pPr indent="0" lvl="0" marL="0" marR="0" rtl="0" algn="l">
+              <a:spcBef>
+                <a:spcPts val="0"/>
+              </a:spcBef>
+              <a:spcAft>
+                <a:spcPts val="0"/>
+              </a:spcAft>
+              <a:buNone/>
+            </a:pPr>
+            <a:r>
+              <a:t/>
+            </a:r>
+            <a:endParaRPr sz="1400">
+              <a:solidFill>
+                <a:schemeClr val="dk1"/>
+              </a:solidFill>
+              <a:latin typeface="Calibri"/>
+              <a:ea typeface="Calibri"/>
+              <a:cs typeface="Calibri"/>
+              <a:sym typeface="Calibri"/>
+            </a:endParaRPr>
+          </a:p>
+        </p:txBody>
+      </p:sp>
+      <p:sp>
+        <p:nvSpPr>
+          <p:cNvPr id="255" name="Google Shape;255;p28"/>
+          <p:cNvSpPr txBox="1"/>
+          <p:nvPr/>
+        </p:nvSpPr>
+        <p:spPr>
+          <a:xfrm>
+            <a:off x="7123888" y="1611630"/>
             <a:ext cx="1543452" cy="288036"/>
           </a:xfrm>
           <a:prstGeom prst="rect">
@@ -25847,26 +26407,34 @@
               </a:rPr>
               <a:t>slot-report skill</a:t>
             </a:r>
-            <a:endParaRPr sz="1100"/>
-          </a:p>
-        </p:txBody>
-      </p:sp>
-      <p:sp>
-        <p:nvSpPr>
-          <p:cNvPr id="245" name="Google Shape;245;p28"/>
+            <a:endParaRPr b="0" i="0" sz="800">
+              <a:solidFill>
+                <a:srgbClr val="2D2D2D"/>
+              </a:solidFill>
+              <a:latin typeface="Calibri"/>
+              <a:ea typeface="Calibri"/>
+              <a:cs typeface="Calibri"/>
+              <a:sym typeface="Calibri"/>
+            </a:endParaRPr>
+          </a:p>
+        </p:txBody>
+      </p:sp>
+      <p:sp>
+        <p:nvSpPr>
+          <p:cNvPr id="256" name="Google Shape;256;p28"/>
           <p:cNvSpPr txBox="1"/>
           <p:nvPr/>
         </p:nvSpPr>
         <p:spPr>
           <a:xfrm>
-            <a:off x="4860159" y="2057400"/>
+            <a:off x="7007272" y="2057400"/>
             <a:ext cx="41159" cy="150876"/>
           </a:xfrm>
           <a:prstGeom prst="rect">
             <a:avLst/>
           </a:prstGeom>
           <a:solidFill>
-            <a:srgbClr val="7C3AED"/>
+            <a:srgbClr val="E86A17"/>
           </a:solidFill>
           <a:ln>
             <a:noFill/>
@@ -25904,13 +26472,13 @@
       </p:sp>
       <p:sp>
         <p:nvSpPr>
-          <p:cNvPr id="246" name="Google Shape;246;p28"/>
+          <p:cNvPr id="257" name="Google Shape;257;p28"/>
           <p:cNvSpPr txBox="1"/>
           <p:nvPr/>
         </p:nvSpPr>
         <p:spPr>
           <a:xfrm>
-            <a:off x="4976775" y="1988820"/>
+            <a:off x="7123888" y="1988820"/>
             <a:ext cx="1543452" cy="288036"/>
           </a:xfrm>
           <a:prstGeom prst="rect">
@@ -25946,7 +26514,7 @@
                 <a:cs typeface="Calibri"/>
                 <a:sym typeface="Calibri"/>
               </a:rPr>
-              <a:t>生成 report.html</a:t>
+              <a:t>report.html</a:t>
             </a:r>
             <a:endParaRPr sz="1100"/>
           </a:p>
@@ -25954,20 +26522,20 @@
       </p:sp>
       <p:sp>
         <p:nvSpPr>
-          <p:cNvPr id="247" name="Google Shape;247;p28"/>
+          <p:cNvPr id="258" name="Google Shape;258;p28"/>
           <p:cNvSpPr txBox="1"/>
           <p:nvPr/>
         </p:nvSpPr>
         <p:spPr>
           <a:xfrm>
-            <a:off x="4860159" y="2434590"/>
+            <a:off x="7007272" y="2434590"/>
             <a:ext cx="41159" cy="150876"/>
           </a:xfrm>
           <a:prstGeom prst="rect">
             <a:avLst/>
           </a:prstGeom>
           <a:solidFill>
-            <a:srgbClr val="7C3AED"/>
+            <a:srgbClr val="E86A17"/>
           </a:solidFill>
           <a:ln>
             <a:noFill/>
@@ -26005,13 +26573,13 @@
       </p:sp>
       <p:sp>
         <p:nvSpPr>
-          <p:cNvPr id="248" name="Google Shape;248;p28"/>
+          <p:cNvPr id="259" name="Google Shape;259;p28"/>
           <p:cNvSpPr txBox="1"/>
           <p:nvPr/>
         </p:nvSpPr>
         <p:spPr>
           <a:xfrm>
-            <a:off x="4976775" y="2366010"/>
+            <a:off x="7123888" y="2366010"/>
             <a:ext cx="1543452" cy="288036"/>
           </a:xfrm>
           <a:prstGeom prst="rect">
@@ -26055,70 +26623,20 @@
       </p:sp>
       <p:sp>
         <p:nvSpPr>
-          <p:cNvPr id="249" name="Google Shape;249;p28"/>
+          <p:cNvPr id="260" name="Google Shape;260;p28"/>
           <p:cNvSpPr txBox="1"/>
           <p:nvPr/>
         </p:nvSpPr>
         <p:spPr>
           <a:xfrm>
-            <a:off x="6650562" y="2606040"/>
-            <a:ext cx="150915" cy="342900"/>
-          </a:xfrm>
-          <a:prstGeom prst="rect">
-            <a:avLst/>
-          </a:prstGeom>
-          <a:noFill/>
-          <a:ln>
-            <a:noFill/>
-          </a:ln>
-        </p:spPr>
-        <p:txBody>
-          <a:bodyPr anchorCtr="0" anchor="ctr" bIns="37500" lIns="37500" spcFirstLastPara="1" rIns="37500" wrap="square" tIns="37500">
-            <a:spAutoFit/>
-          </a:bodyPr>
-          <a:lstStyle/>
-          <a:p>
-            <a:pPr indent="0" lvl="0" marL="0" marR="0" rtl="0" algn="ctr">
-              <a:spcBef>
-                <a:spcPts val="0"/>
-              </a:spcBef>
-              <a:spcAft>
-                <a:spcPts val="0"/>
-              </a:spcAft>
-              <a:buNone/>
-            </a:pPr>
-            <a:r>
-              <a:rPr b="1" i="0" lang="zh-TW" sz="1100">
-                <a:solidFill>
-                  <a:srgbClr val="FCA311"/>
-                </a:solidFill>
-                <a:latin typeface="Calibri"/>
-                <a:ea typeface="Calibri"/>
-                <a:cs typeface="Calibri"/>
-                <a:sym typeface="Calibri"/>
-              </a:rPr>
-              <a:t>▶</a:t>
-            </a:r>
-            <a:endParaRPr sz="1100"/>
-          </a:p>
-        </p:txBody>
-      </p:sp>
-      <p:sp>
-        <p:nvSpPr>
-          <p:cNvPr id="250" name="Google Shape;250;p28"/>
-          <p:cNvSpPr txBox="1"/>
-          <p:nvPr/>
-        </p:nvSpPr>
-        <p:spPr>
-          <a:xfrm>
-            <a:off x="6815198" y="1028700"/>
-            <a:ext cx="1955039" cy="2606040"/>
+            <a:off x="342989" y="4834890"/>
+            <a:ext cx="8458117" cy="219456"/>
           </a:xfrm>
           <a:prstGeom prst="rect">
             <a:avLst/>
           </a:prstGeom>
           <a:solidFill>
-            <a:srgbClr val="F4F5F7"/>
+            <a:srgbClr val="FFEFCC"/>
           </a:solidFill>
           <a:ln>
             <a:noFill/>
@@ -26156,519 +26674,6 @@
       </p:sp>
       <p:sp>
         <p:nvSpPr>
-          <p:cNvPr id="251" name="Google Shape;251;p28"/>
-          <p:cNvSpPr txBox="1"/>
-          <p:nvPr/>
-        </p:nvSpPr>
-        <p:spPr>
-          <a:xfrm>
-            <a:off x="6815198" y="1028700"/>
-            <a:ext cx="1955039" cy="425196"/>
-          </a:xfrm>
-          <a:prstGeom prst="rect">
-            <a:avLst/>
-          </a:prstGeom>
-          <a:solidFill>
-            <a:srgbClr val="E86A17"/>
-          </a:solidFill>
-          <a:ln>
-            <a:noFill/>
-          </a:ln>
-        </p:spPr>
-        <p:txBody>
-          <a:bodyPr anchorCtr="0" anchor="t" bIns="34275" lIns="68575" spcFirstLastPara="1" rIns="68575" wrap="square" tIns="34275">
-            <a:spAutoFit/>
-          </a:bodyPr>
-          <a:lstStyle/>
-          <a:p>
-            <a:pPr indent="0" lvl="0" marL="0" marR="0" rtl="0" algn="l">
-              <a:spcBef>
-                <a:spcPts val="0"/>
-              </a:spcBef>
-              <a:spcAft>
-                <a:spcPts val="0"/>
-              </a:spcAft>
-              <a:buNone/>
-            </a:pPr>
-            <a:r>
-              <a:t/>
-            </a:r>
-            <a:endParaRPr sz="1400">
-              <a:solidFill>
-                <a:schemeClr val="dk1"/>
-              </a:solidFill>
-              <a:latin typeface="Calibri"/>
-              <a:ea typeface="Calibri"/>
-              <a:cs typeface="Calibri"/>
-              <a:sym typeface="Calibri"/>
-            </a:endParaRPr>
-          </a:p>
-        </p:txBody>
-      </p:sp>
-      <p:sp>
-        <p:nvSpPr>
-          <p:cNvPr id="252" name="Google Shape;252;p28"/>
-          <p:cNvSpPr txBox="1"/>
-          <p:nvPr/>
-        </p:nvSpPr>
-        <p:spPr>
-          <a:xfrm>
-            <a:off x="6918095" y="1097280"/>
-            <a:ext cx="329270" cy="308610"/>
-          </a:xfrm>
-          <a:prstGeom prst="rect">
-            <a:avLst/>
-          </a:prstGeom>
-          <a:noFill/>
-          <a:ln>
-            <a:noFill/>
-          </a:ln>
-        </p:spPr>
-        <p:txBody>
-          <a:bodyPr anchorCtr="0" anchor="t" bIns="37500" lIns="37500" spcFirstLastPara="1" rIns="37500" wrap="square" tIns="37500">
-            <a:spAutoFit/>
-          </a:bodyPr>
-          <a:lstStyle/>
-          <a:p>
-            <a:pPr indent="0" lvl="0" marL="0" marR="0" rtl="0" algn="l">
-              <a:spcBef>
-                <a:spcPts val="0"/>
-              </a:spcBef>
-              <a:spcAft>
-                <a:spcPts val="0"/>
-              </a:spcAft>
-              <a:buNone/>
-            </a:pPr>
-            <a:r>
-              <a:rPr b="1" i="0" lang="zh-TW" sz="1400">
-                <a:solidFill>
-                  <a:srgbClr val="FFFFFF"/>
-                </a:solidFill>
-                <a:latin typeface="Calibri"/>
-                <a:ea typeface="Calibri"/>
-                <a:cs typeface="Calibri"/>
-                <a:sym typeface="Calibri"/>
-              </a:rPr>
-              <a:t>04</a:t>
-            </a:r>
-            <a:endParaRPr sz="1100"/>
-          </a:p>
-        </p:txBody>
-      </p:sp>
-      <p:sp>
-        <p:nvSpPr>
-          <p:cNvPr id="253" name="Google Shape;253;p28"/>
-          <p:cNvSpPr txBox="1"/>
-          <p:nvPr/>
-        </p:nvSpPr>
-        <p:spPr>
-          <a:xfrm>
-            <a:off x="7192486" y="1083564"/>
-            <a:ext cx="1474854" cy="329184"/>
-          </a:xfrm>
-          <a:prstGeom prst="rect">
-            <a:avLst/>
-          </a:prstGeom>
-          <a:noFill/>
-          <a:ln>
-            <a:noFill/>
-          </a:ln>
-        </p:spPr>
-        <p:txBody>
-          <a:bodyPr anchorCtr="0" anchor="t" bIns="37500" lIns="37500" spcFirstLastPara="1" rIns="37500" wrap="square" tIns="37500">
-            <a:spAutoFit/>
-          </a:bodyPr>
-          <a:lstStyle/>
-          <a:p>
-            <a:pPr indent="0" lvl="0" marL="0" marR="0" rtl="0" algn="l">
-              <a:spcBef>
-                <a:spcPts val="0"/>
-              </a:spcBef>
-              <a:spcAft>
-                <a:spcPts val="0"/>
-              </a:spcAft>
-              <a:buNone/>
-            </a:pPr>
-            <a:r>
-              <a:rPr b="1" i="0" lang="zh-TW" sz="900">
-                <a:solidFill>
-                  <a:srgbClr val="FFFFFF"/>
-                </a:solidFill>
-                <a:latin typeface="Calibri"/>
-                <a:ea typeface="Calibri"/>
-                <a:cs typeface="Calibri"/>
-                <a:sym typeface="Calibri"/>
-              </a:rPr>
-              <a:t>備份 / 輸出 Figma</a:t>
-            </a:r>
-            <a:endParaRPr sz="1100"/>
-          </a:p>
-        </p:txBody>
-      </p:sp>
-      <p:sp>
-        <p:nvSpPr>
-          <p:cNvPr id="254" name="Google Shape;254;p28"/>
-          <p:cNvSpPr txBox="1"/>
-          <p:nvPr/>
-        </p:nvSpPr>
-        <p:spPr>
-          <a:xfrm>
-            <a:off x="7007272" y="1680210"/>
-            <a:ext cx="41159" cy="150876"/>
-          </a:xfrm>
-          <a:prstGeom prst="rect">
-            <a:avLst/>
-          </a:prstGeom>
-          <a:solidFill>
-            <a:srgbClr val="E86A17"/>
-          </a:solidFill>
-          <a:ln>
-            <a:noFill/>
-          </a:ln>
-        </p:spPr>
-        <p:txBody>
-          <a:bodyPr anchorCtr="0" anchor="t" bIns="34275" lIns="68575" spcFirstLastPara="1" rIns="68575" wrap="square" tIns="34275">
-            <a:spAutoFit/>
-          </a:bodyPr>
-          <a:lstStyle/>
-          <a:p>
-            <a:pPr indent="0" lvl="0" marL="0" marR="0" rtl="0" algn="l">
-              <a:spcBef>
-                <a:spcPts val="0"/>
-              </a:spcBef>
-              <a:spcAft>
-                <a:spcPts val="0"/>
-              </a:spcAft>
-              <a:buNone/>
-            </a:pPr>
-            <a:r>
-              <a:t/>
-            </a:r>
-            <a:endParaRPr sz="1400">
-              <a:solidFill>
-                <a:schemeClr val="dk1"/>
-              </a:solidFill>
-              <a:latin typeface="Calibri"/>
-              <a:ea typeface="Calibri"/>
-              <a:cs typeface="Calibri"/>
-              <a:sym typeface="Calibri"/>
-            </a:endParaRPr>
-          </a:p>
-        </p:txBody>
-      </p:sp>
-      <p:sp>
-        <p:nvSpPr>
-          <p:cNvPr id="255" name="Google Shape;255;p28"/>
-          <p:cNvSpPr txBox="1"/>
-          <p:nvPr/>
-        </p:nvSpPr>
-        <p:spPr>
-          <a:xfrm>
-            <a:off x="7123888" y="1611630"/>
-            <a:ext cx="1543452" cy="288036"/>
-          </a:xfrm>
-          <a:prstGeom prst="rect">
-            <a:avLst/>
-          </a:prstGeom>
-          <a:noFill/>
-          <a:ln>
-            <a:noFill/>
-          </a:ln>
-        </p:spPr>
-        <p:txBody>
-          <a:bodyPr anchorCtr="0" anchor="t" bIns="37500" lIns="37500" spcFirstLastPara="1" rIns="37500" wrap="square" tIns="37500">
-            <a:spAutoFit/>
-          </a:bodyPr>
-          <a:lstStyle/>
-          <a:p>
-            <a:pPr indent="0" lvl="0" marL="0" marR="0" rtl="0" algn="l">
-              <a:spcBef>
-                <a:spcPts val="0"/>
-              </a:spcBef>
-              <a:spcAft>
-                <a:spcPts val="0"/>
-              </a:spcAft>
-              <a:buNone/>
-            </a:pPr>
-            <a:r>
-              <a:rPr b="0" i="0" lang="zh-TW" sz="800">
-                <a:solidFill>
-                  <a:srgbClr val="2D2D2D"/>
-                </a:solidFill>
-                <a:latin typeface="Calibri"/>
-                <a:ea typeface="Calibri"/>
-                <a:cs typeface="Calibri"/>
-                <a:sym typeface="Calibri"/>
-              </a:rPr>
-              <a:t>archive_to_fileserver</a:t>
-            </a:r>
-            <a:endParaRPr b="0" i="0" sz="800">
-              <a:solidFill>
-                <a:srgbClr val="2D2D2D"/>
-              </a:solidFill>
-              <a:latin typeface="Calibri"/>
-              <a:ea typeface="Calibri"/>
-              <a:cs typeface="Calibri"/>
-              <a:sym typeface="Calibri"/>
-            </a:endParaRPr>
-          </a:p>
-        </p:txBody>
-      </p:sp>
-      <p:sp>
-        <p:nvSpPr>
-          <p:cNvPr id="256" name="Google Shape;256;p28"/>
-          <p:cNvSpPr txBox="1"/>
-          <p:nvPr/>
-        </p:nvSpPr>
-        <p:spPr>
-          <a:xfrm>
-            <a:off x="7007272" y="2057400"/>
-            <a:ext cx="41159" cy="150876"/>
-          </a:xfrm>
-          <a:prstGeom prst="rect">
-            <a:avLst/>
-          </a:prstGeom>
-          <a:solidFill>
-            <a:srgbClr val="E86A17"/>
-          </a:solidFill>
-          <a:ln>
-            <a:noFill/>
-          </a:ln>
-        </p:spPr>
-        <p:txBody>
-          <a:bodyPr anchorCtr="0" anchor="t" bIns="34275" lIns="68575" spcFirstLastPara="1" rIns="68575" wrap="square" tIns="34275">
-            <a:spAutoFit/>
-          </a:bodyPr>
-          <a:lstStyle/>
-          <a:p>
-            <a:pPr indent="0" lvl="0" marL="0" marR="0" rtl="0" algn="l">
-              <a:spcBef>
-                <a:spcPts val="0"/>
-              </a:spcBef>
-              <a:spcAft>
-                <a:spcPts val="0"/>
-              </a:spcAft>
-              <a:buNone/>
-            </a:pPr>
-            <a:r>
-              <a:t/>
-            </a:r>
-            <a:endParaRPr sz="1400">
-              <a:solidFill>
-                <a:schemeClr val="dk1"/>
-              </a:solidFill>
-              <a:latin typeface="Calibri"/>
-              <a:ea typeface="Calibri"/>
-              <a:cs typeface="Calibri"/>
-              <a:sym typeface="Calibri"/>
-            </a:endParaRPr>
-          </a:p>
-        </p:txBody>
-      </p:sp>
-      <p:sp>
-        <p:nvSpPr>
-          <p:cNvPr id="257" name="Google Shape;257;p28"/>
-          <p:cNvSpPr txBox="1"/>
-          <p:nvPr/>
-        </p:nvSpPr>
-        <p:spPr>
-          <a:xfrm>
-            <a:off x="7123888" y="1988820"/>
-            <a:ext cx="1543452" cy="288036"/>
-          </a:xfrm>
-          <a:prstGeom prst="rect">
-            <a:avLst/>
-          </a:prstGeom>
-          <a:noFill/>
-          <a:ln>
-            <a:noFill/>
-          </a:ln>
-        </p:spPr>
-        <p:txBody>
-          <a:bodyPr anchorCtr="0" anchor="t" bIns="37500" lIns="37500" spcFirstLastPara="1" rIns="37500" wrap="square" tIns="37500">
-            <a:spAutoFit/>
-          </a:bodyPr>
-          <a:lstStyle/>
-          <a:p>
-            <a:pPr indent="0" lvl="0" marL="0" marR="0" rtl="0" algn="l">
-              <a:spcBef>
-                <a:spcPts val="0"/>
-              </a:spcBef>
-              <a:spcAft>
-                <a:spcPts val="0"/>
-              </a:spcAft>
-              <a:buNone/>
-            </a:pPr>
-            <a:r>
-              <a:rPr b="0" i="0" lang="zh-TW" sz="800">
-                <a:solidFill>
-                  <a:srgbClr val="2D2D2D"/>
-                </a:solidFill>
-                <a:latin typeface="Calibri"/>
-                <a:ea typeface="Calibri"/>
-                <a:cs typeface="Calibri"/>
-                <a:sym typeface="Calibri"/>
-              </a:rPr>
-              <a:t>run_figma_export</a:t>
-            </a:r>
-            <a:endParaRPr sz="1100"/>
-          </a:p>
-        </p:txBody>
-      </p:sp>
-      <p:sp>
-        <p:nvSpPr>
-          <p:cNvPr id="258" name="Google Shape;258;p28"/>
-          <p:cNvSpPr txBox="1"/>
-          <p:nvPr/>
-        </p:nvSpPr>
-        <p:spPr>
-          <a:xfrm>
-            <a:off x="7007272" y="2434590"/>
-            <a:ext cx="41159" cy="150876"/>
-          </a:xfrm>
-          <a:prstGeom prst="rect">
-            <a:avLst/>
-          </a:prstGeom>
-          <a:solidFill>
-            <a:srgbClr val="E86A17"/>
-          </a:solidFill>
-          <a:ln>
-            <a:noFill/>
-          </a:ln>
-        </p:spPr>
-        <p:txBody>
-          <a:bodyPr anchorCtr="0" anchor="t" bIns="34275" lIns="68575" spcFirstLastPara="1" rIns="68575" wrap="square" tIns="34275">
-            <a:spAutoFit/>
-          </a:bodyPr>
-          <a:lstStyle/>
-          <a:p>
-            <a:pPr indent="0" lvl="0" marL="0" marR="0" rtl="0" algn="l">
-              <a:spcBef>
-                <a:spcPts val="0"/>
-              </a:spcBef>
-              <a:spcAft>
-                <a:spcPts val="0"/>
-              </a:spcAft>
-              <a:buNone/>
-            </a:pPr>
-            <a:r>
-              <a:t/>
-            </a:r>
-            <a:endParaRPr sz="1400">
-              <a:solidFill>
-                <a:schemeClr val="dk1"/>
-              </a:solidFill>
-              <a:latin typeface="Calibri"/>
-              <a:ea typeface="Calibri"/>
-              <a:cs typeface="Calibri"/>
-              <a:sym typeface="Calibri"/>
-            </a:endParaRPr>
-          </a:p>
-        </p:txBody>
-      </p:sp>
-      <p:sp>
-        <p:nvSpPr>
-          <p:cNvPr id="259" name="Google Shape;259;p28"/>
-          <p:cNvSpPr txBox="1"/>
-          <p:nvPr/>
-        </p:nvSpPr>
-        <p:spPr>
-          <a:xfrm>
-            <a:off x="7123888" y="2366010"/>
-            <a:ext cx="1543452" cy="288036"/>
-          </a:xfrm>
-          <a:prstGeom prst="rect">
-            <a:avLst/>
-          </a:prstGeom>
-          <a:noFill/>
-          <a:ln>
-            <a:noFill/>
-          </a:ln>
-        </p:spPr>
-        <p:txBody>
-          <a:bodyPr anchorCtr="0" anchor="t" bIns="37500" lIns="37500" spcFirstLastPara="1" rIns="37500" wrap="square" tIns="37500">
-            <a:spAutoFit/>
-          </a:bodyPr>
-          <a:lstStyle/>
-          <a:p>
-            <a:pPr indent="0" lvl="0" marL="0" marR="0" rtl="0" algn="l">
-              <a:spcBef>
-                <a:spcPts val="0"/>
-              </a:spcBef>
-              <a:spcAft>
-                <a:spcPts val="0"/>
-              </a:spcAft>
-              <a:buNone/>
-            </a:pPr>
-            <a:r>
-              <a:rPr b="0" i="0" lang="zh-TW" sz="800">
-                <a:solidFill>
-                  <a:srgbClr val="2D2D2D"/>
-                </a:solidFill>
-                <a:latin typeface="Calibri"/>
-                <a:ea typeface="Calibri"/>
-                <a:cs typeface="Calibri"/>
-                <a:sym typeface="Calibri"/>
-              </a:rPr>
-              <a:t>Figma Board 匯入</a:t>
-            </a:r>
-            <a:endParaRPr sz="1100"/>
-          </a:p>
-        </p:txBody>
-      </p:sp>
-      <p:sp>
-        <p:nvSpPr>
-          <p:cNvPr id="260" name="Google Shape;260;p28"/>
-          <p:cNvSpPr txBox="1"/>
-          <p:nvPr/>
-        </p:nvSpPr>
-        <p:spPr>
-          <a:xfrm>
-            <a:off x="342989" y="4834890"/>
-            <a:ext cx="8458117" cy="219456"/>
-          </a:xfrm>
-          <a:prstGeom prst="rect">
-            <a:avLst/>
-          </a:prstGeom>
-          <a:solidFill>
-            <a:srgbClr val="FFEFCC"/>
-          </a:solidFill>
-          <a:ln>
-            <a:noFill/>
-          </a:ln>
-        </p:spPr>
-        <p:txBody>
-          <a:bodyPr anchorCtr="0" anchor="t" bIns="34275" lIns="68575" spcFirstLastPara="1" rIns="68575" wrap="square" tIns="34275">
-            <a:spAutoFit/>
-          </a:bodyPr>
-          <a:lstStyle/>
-          <a:p>
-            <a:pPr indent="0" lvl="0" marL="0" marR="0" rtl="0" algn="l">
-              <a:spcBef>
-                <a:spcPts val="0"/>
-              </a:spcBef>
-              <a:spcAft>
-                <a:spcPts val="0"/>
-              </a:spcAft>
-              <a:buNone/>
-            </a:pPr>
-            <a:r>
-              <a:t/>
-            </a:r>
-            <a:endParaRPr sz="1400">
-              <a:solidFill>
-                <a:schemeClr val="dk1"/>
-              </a:solidFill>
-              <a:latin typeface="Calibri"/>
-              <a:ea typeface="Calibri"/>
-              <a:cs typeface="Calibri"/>
-              <a:sym typeface="Calibri"/>
-            </a:endParaRPr>
-          </a:p>
-        </p:txBody>
-      </p:sp>
-      <p:sp>
-        <p:nvSpPr>
           <p:cNvPr id="261" name="Google Shape;261;p28"/>
           <p:cNvSpPr txBox="1"/>
           <p:nvPr/>
@@ -26711,7 +26716,7 @@
                 <a:cs typeface="Calibri"/>
                 <a:sym typeface="Calibri"/>
               </a:rPr>
-              <a:t>⚠  每個步驟均有對應的 PowerShell 腳本，可單獨執行，也可依需求彈性組合</a:t>
+              <a:t>在專案根目錄執行 claude 後，只需輸入「幫我分析 GameName」即可串聯全部步驟</a:t>
             </a:r>
             <a:endParaRPr sz="1100"/>
           </a:p>
@@ -27294,7 +27299,7 @@
                 <a:cs typeface="Calibri"/>
                 <a:sym typeface="Calibri"/>
               </a:rPr>
-              <a:t>4.2  主程式使用方式</a:t>
+              <a:t>4.2  ROI 確認與分類流程</a:t>
             </a:r>
             <a:endParaRPr sz="1100"/>
           </a:p>
@@ -27447,7 +27452,7 @@
                 <a:cs typeface="Calibri"/>
                 <a:sym typeface="Calibri"/>
               </a:rPr>
-              <a:t>4.3  Claude Skill 建立與呼叫</a:t>
+              <a:t>4.3  人工審核修正</a:t>
             </a:r>
             <a:endParaRPr sz="1100"/>
           </a:p>
@@ -27600,7 +27605,7 @@
                 <a:cs typeface="Calibri"/>
                 <a:sym typeface="Calibri"/>
               </a:rPr>
-              <a:t>4.4  Figma Board 匯入方式</a:t>
+              <a:t>4.4  Claude Skill 競品報告</a:t>
             </a:r>
             <a:endParaRPr sz="1100"/>
           </a:p>
@@ -27753,7 +27758,7 @@
                 <a:cs typeface="Calibri"/>
                 <a:sym typeface="Calibri"/>
               </a:rPr>
-              <a:t>4.5  備份至 Fileserver</a:t>
+              <a:t>4.5  GitHub 取得最新版本</a:t>
             </a:r>
             <a:endParaRPr sz="1100"/>
           </a:p>
@@ -28249,7 +28254,7 @@
                 <a:cs typeface="Calibri"/>
                 <a:sym typeface="Calibri"/>
               </a:rPr>
-              <a:t>建立虛擬環境並安裝套件</a:t>
+              <a:t>取得專案並建立虛擬環境</a:t>
             </a:r>
             <a:endParaRPr sz="1100"/>
           </a:p>
@@ -28299,7 +28304,7 @@
                 <a:cs typeface="Calibri"/>
                 <a:sym typeface="Calibri"/>
               </a:rPr>
-              <a:t>自動建立 .venv 並安裝 numpy、opencv、paddleocr 等相依套件</a:t>
+              <a:t>git clone + checkout perf/cpu-optimize-ocr，再建立 .venv 安裝套件</a:t>
             </a:r>
             <a:endParaRPr sz="1100"/>
           </a:p>
@@ -28406,7 +28411,9 @@
                 <a:cs typeface="Consolas"/>
                 <a:sym typeface="Consolas"/>
               </a:rPr>
-              <a:t>PS&gt;  .\setup_venv.ps1</a:t>
+              <a:t>git clone https://github.com/Ashley860511/slot-classifier.git
+git checkout perf/cpu-optimize-ocr
+pip install -r requirements.txt</a:t>
             </a:r>
             <a:endParaRPr sz="1100"/>
           </a:p>
@@ -28559,7 +28566,7 @@
                 <a:cs typeface="Calibri"/>
                 <a:sym typeface="Calibri"/>
               </a:rPr>
-              <a:t>確認環境正常</a:t>
+              <a:t>安裝 Claude Code CLI</a:t>
             </a:r>
             <a:endParaRPr sz="1100"/>
           </a:p>
@@ -28609,7 +28616,7 @@
                 <a:cs typeface="Calibri"/>
                 <a:sym typeface="Calibri"/>
               </a:rPr>
-              <a:t>執行環境檢查，確認所有套件版本與相依性無誤</a:t>
+              <a:t>需要 Node.js 18+。安裝後執行 claude login 完成帳號綁定</a:t>
             </a:r>
             <a:endParaRPr sz="1100"/>
           </a:p>
@@ -28716,7 +28723,8 @@
                 <a:cs typeface="Consolas"/>
                 <a:sym typeface="Consolas"/>
               </a:rPr>
-              <a:t>PS&gt;  .\check_environment.ps1</a:t>
+              <a:t>npm install -g @anthropic/claude-code
+claude login</a:t>
             </a:r>
             <a:endParaRPr sz="1100"/>
           </a:p>
@@ -28869,7 +28877,7 @@
                 <a:cs typeface="Calibri"/>
                 <a:sym typeface="Calibri"/>
               </a:rPr>
-              <a:t>首次執行自動下載 OCR 模型</a:t>
+              <a:t>確認環境並首次執行</a:t>
             </a:r>
             <a:endParaRPr sz="1100"/>
           </a:p>
@@ -28919,7 +28927,7 @@
                 <a:cs typeface="Calibri"/>
                 <a:sym typeface="Calibri"/>
               </a:rPr>
-              <a:t>PaddleOCR 模型約 50MB，首次執行時自動下載，需確保網路連線</a:t>
+              <a:t>python check_environment.py 確認套件無誤。首次分類時 PaddleOCR 自動下載語言模型（約 300 MB）</a:t>
             </a:r>
             <a:endParaRPr sz="1100"/>
           </a:p>
@@ -29540,7 +29548,7 @@
                 <a:cs typeface="Calibri"/>
                 <a:sym typeface="Calibri"/>
               </a:rPr>
-              <a:t>主程式使用方式</a:t>
+              <a:t>ROI 確認與分類流程</a:t>
             </a:r>
             <a:endParaRPr sz="1100"/>
           </a:p>
@@ -29590,7 +29598,7 @@
                 <a:cs typeface="Calibri"/>
                 <a:sym typeface="Calibri"/>
               </a:rPr>
-              <a:t>Running the Classifier</a:t>
+              <a:t>ROI Confirmation &amp; Classification</a:t>
             </a:r>
             <a:endParaRPr sz="1100"/>
           </a:p>
@@ -29697,7 +29705,7 @@
                 <a:cs typeface="Calibri"/>
                 <a:sym typeface="Calibri"/>
               </a:rPr>
-              <a:t>4.2  主程式</a:t>
+              <a:t>4.2  ROI 確認與分類</a:t>
             </a:r>
             <a:endParaRPr sz="1100"/>
           </a:p>
@@ -29849,7 +29857,7 @@
                 <a:cs typeface="Calibri"/>
                 <a:sym typeface="Calibri"/>
               </a:rPr>
-              <a:t>將競品遊戲影片（.mp4）放入以下資料夾，支援多個影片一次處理</a:t>
+              <a:t>將競品遊戲影片（.mp4）放入資料夾。在專案根目錄啟動 Claude Code</a:t>
             </a:r>
             <a:endParaRPr sz="900">
               <a:solidFill>
@@ -29881,7 +29889,7 @@
                 <a:cs typeface="Calibri"/>
                 <a:sym typeface="Calibri"/>
               </a:rPr>
-              <a:t>請確保影片錄製完整，包含競品分析所需資料</a:t>
+              <a:t>然後輸入：幫我分析 GameName</a:t>
             </a:r>
             <a:endParaRPr sz="900">
               <a:solidFill>
@@ -29996,7 +30004,8 @@
                 <a:cs typeface="Consolas"/>
                 <a:sym typeface="Consolas"/>
               </a:rPr>
-              <a:t>project\input_videos\GameName.mp4</a:t>
+              <a:t>project/input_videos/GameName.mp4
+$ claude → 幫我分析 GameName</a:t>
             </a:r>
             <a:endParaRPr sz="1100"/>
           </a:p>
@@ -30149,7 +30158,7 @@
                 <a:cs typeface="Calibri"/>
                 <a:sym typeface="Calibri"/>
               </a:rPr>
-              <a:t>執行分類主程式</a:t>
+              <a:t>確認 ROI 邊框</a:t>
             </a:r>
             <a:endParaRPr sz="1100"/>
           </a:p>
@@ -30199,7 +30208,7 @@
                 <a:cs typeface="Calibri"/>
                 <a:sym typeface="Calibri"/>
               </a:rPr>
-              <a:t>一般執行處理所有影片；可加 GameName 參數指定單一遊戲</a:t>
+              <a:t>Claude 輸出 WAITING_ROI_CONFIRM 後，用瀏覽器開啟 _debug/roi_adjust.html 確認遊戲畫面邊框</a:t>
             </a:r>
             <a:endParaRPr sz="1100"/>
           </a:p>
@@ -30306,7 +30315,7 @@
                 <a:cs typeface="Consolas"/>
                 <a:sym typeface="Consolas"/>
               </a:rPr>
-              <a:t>.\run_classifier.ps1</a:t>
+              <a:t>回覆：ROI 確認：x,y,w,h  或  ROI OK</a:t>
             </a:r>
             <a:endParaRPr sz="1100"/>
           </a:p>
@@ -30531,7 +30540,7 @@
                 <a:cs typeface="Calibri"/>
                 <a:sym typeface="Calibri"/>
               </a:rPr>
-              <a:t>確認輸出結果</a:t>
+              <a:t>分類完成，人工審核</a:t>
             </a:r>
             <a:endParaRPr sz="1100"/>
           </a:p>
@@ -30581,7 +30590,7 @@
                 <a:cs typeface="Calibri"/>
                 <a:sym typeface="Calibri"/>
               </a:rPr>
-              <a:t>每款遊戲獨立資料夾，包含分類截圖、CSV 統計表與低信心值截圖</a:t>
+              <a:t>分類後 review server 自動啟動，開瀏覽器前往 localhost:8765 進行人工審核修正</a:t>
             </a:r>
             <a:endParaRPr sz="1100"/>
           </a:p>
@@ -30688,7 +30697,7 @@
                 <a:cs typeface="Consolas"/>
                 <a:sym typeface="Consolas"/>
               </a:rPr>
-              <a:t>project\output\GameName\</a:t>
+              <a:t>http://localhost:8765</a:t>
             </a:r>
             <a:endParaRPr sz="1100"/>
           </a:p>
@@ -31189,7 +31198,7 @@
                 <a:cs typeface="Consolas"/>
                 <a:sym typeface="Consolas"/>
               </a:rPr>
-              <a:t>  ├ low_score/</a:t>
+              <a:t>  ├ needs_review/</a:t>
             </a:r>
             <a:endParaRPr sz="1100"/>
           </a:p>
@@ -31239,7 +31248,7 @@
                 <a:cs typeface="Consolas"/>
                 <a:sym typeface="Consolas"/>
               </a:rPr>
-              <a:t>  ├ cls_result.csv</a:t>
+              <a:t>  ├ classification_result.csv</a:t>
             </a:r>
             <a:endParaRPr sz="1100"/>
           </a:p>
@@ -31633,7 +31642,7 @@
                 <a:cs typeface="Calibri"/>
                 <a:sym typeface="Calibri"/>
               </a:rPr>
-              <a:t>Claude Skill — 競品報告生成</a:t>
+              <a:t>人工審核修正</a:t>
             </a:r>
             <a:endParaRPr sz="1100"/>
           </a:p>
@@ -31683,7 +31692,7 @@
                 <a:cs typeface="Calibri"/>
                 <a:sym typeface="Calibri"/>
               </a:rPr>
-              <a:t>Creating &amp; Calling the slot-report Skill</a:t>
+              <a:t>Review &amp; Apply Corrections</a:t>
             </a:r>
             <a:endParaRPr sz="1100"/>
           </a:p>
@@ -31790,7 +31799,7 @@
                 <a:cs typeface="Calibri"/>
                 <a:sym typeface="Calibri"/>
               </a:rPr>
-              <a:t>4.3  Claude Skill</a:t>
+              <a:t>4.3  人工審核修正</a:t>
             </a:r>
             <a:endParaRPr sz="1100"/>
           </a:p>
@@ -31942,7 +31951,7 @@
                 <a:cs typeface="Calibri"/>
                 <a:sym typeface="Calibri"/>
               </a:rPr>
-              <a:t>安裝 Skill</a:t>
+              <a:t>信心等級</a:t>
             </a:r>
             <a:endParaRPr sz="1100"/>
           </a:p>
@@ -32095,7 +32104,7 @@
                 <a:cs typeface="Calibri"/>
                 <a:sym typeface="Calibri"/>
               </a:rPr>
-              <a:t>找到 Skills 資料夾</a:t>
+              <a:t>high — 分類確定（綠色）</a:t>
             </a:r>
             <a:endParaRPr sz="1100"/>
           </a:p>
@@ -32145,7 +32154,7 @@
                 <a:cs typeface="Calibri"/>
                 <a:sym typeface="Calibri"/>
               </a:rPr>
-              <a:t>%APPDATA%\Claude\...\skills\</a:t>
+              <a:t>直接跳過，無需確認</a:t>
             </a:r>
             <a:endParaRPr sz="1100"/>
           </a:p>
@@ -32298,7 +32307,7 @@
                 <a:cs typeface="Calibri"/>
                 <a:sym typeface="Calibri"/>
               </a:rPr>
-              <a:t>建立 slot-report/ 子目錄</a:t>
+              <a:t>medium — 邊界模糊（黃色）</a:t>
             </a:r>
             <a:endParaRPr sz="1100"/>
           </a:p>
@@ -32348,7 +32357,7 @@
                 <a:cs typeface="Calibri"/>
                 <a:sym typeface="Calibri"/>
               </a:rPr>
-              <a:t>在 skills/ 內新增 slot-report 資料夾</a:t>
+              <a:t>快速掃一眼，有問題再修正</a:t>
             </a:r>
             <a:endParaRPr sz="1100"/>
           </a:p>
@@ -32501,7 +32510,7 @@
                 <a:cs typeface="Calibri"/>
                 <a:sym typeface="Calibri"/>
               </a:rPr>
-              <a:t>複製 claude/Skill.md 內容</a:t>
+              <a:t>low — 信心不足（紅色）</a:t>
             </a:r>
             <a:endParaRPr sz="1100"/>
           </a:p>
@@ -32551,7 +32560,7 @@
                 <a:cs typeface="Calibri"/>
                 <a:sym typeface="Calibri"/>
               </a:rPr>
-              <a:t>貼入 slot-report/SKILL.md 並儲存</a:t>
+              <a:t>建議確認，改分類或排除</a:t>
             </a:r>
             <a:endParaRPr sz="1100"/>
           </a:p>
@@ -32704,7 +32713,7 @@
                 <a:cs typeface="Calibri"/>
                 <a:sym typeface="Calibri"/>
               </a:rPr>
-              <a:t>重新啟動 Claude Code</a:t>
+              <a:t/>
             </a:r>
             <a:endParaRPr sz="1100"/>
           </a:p>
@@ -32754,7 +32763,7 @@
                 <a:cs typeface="Calibri"/>
                 <a:sym typeface="Calibri"/>
               </a:rPr>
-              <a:t>Skill 即可在對話中使用</a:t>
+              <a:t/>
             </a:r>
             <a:endParaRPr sz="1100"/>
           </a:p>
@@ -32906,7 +32915,7 @@
                 <a:cs typeface="Calibri"/>
                 <a:sym typeface="Calibri"/>
               </a:rPr>
-              <a:t>呼叫 Skill</a:t>
+              <a:t>操作方式</a:t>
             </a:r>
             <a:endParaRPr sz="1100"/>
           </a:p>
@@ -32956,7 +32965,7 @@
                 <a:cs typeface="Calibri"/>
                 <a:sym typeface="Calibri"/>
               </a:rPr>
-              <a:t>在 Claude Code 輸入：</a:t>
+              <a:t>瀏覽器開啟 http://localhost:8765</a:t>
             </a:r>
             <a:endParaRPr sz="1100"/>
           </a:p>
@@ -33063,7 +33072,8 @@
                 <a:cs typeface="Consolas"/>
                 <a:sym typeface="Consolas"/>
               </a:rPr>
-              <a:t>幫我分析 project/output/GameName 這款遊戲，生成 report.html</a:t>
+              <a:t>每張截圖可選擇：✅ 正確 / 🔀 改分類 / 🗑️ 排除
+完成後按「套用修正」，CSV 與截圖自動更新</a:t>
             </a:r>
             <a:endParaRPr sz="1100"/>
           </a:p>
@@ -33113,7 +33123,7 @@
                 <a:cs typeface="Calibri"/>
                 <a:sym typeface="Calibri"/>
               </a:rPr>
-              <a:t>報告三大段落：</a:t>
+              <a:t>review server 說明：</a:t>
             </a:r>
             <a:endParaRPr sz="1100"/>
           </a:p>
@@ -33266,7 +33276,7 @@
                 <a:cs typeface="Calibri"/>
                 <a:sym typeface="Calibri"/>
               </a:rPr>
-              <a:t>符號賠率表</a:t>
+              <a:t>自動啟動</a:t>
             </a:r>
             <a:endParaRPr sz="1100"/>
           </a:p>
@@ -33316,7 +33326,7 @@
                 <a:cs typeface="Calibri"/>
                 <a:sym typeface="Calibri"/>
               </a:rPr>
-              <a:t>特殊符號（Scatter/Wild）、主力符號、低值符號，各附圖片與賠率</a:t>
+              <a:t>分類完成後由 classify_with_roi_confirm.sh 自動啟動</a:t>
             </a:r>
             <a:endParaRPr sz="1100"/>
           </a:p>
@@ -33469,7 +33479,7 @@
                 <a:cs typeface="Calibri"/>
                 <a:sym typeface="Calibri"/>
               </a:rPr>
-              <a:t>玩法機制</a:t>
+              <a:t>port 8765</a:t>
             </a:r>
             <a:endParaRPr sz="1100"/>
           </a:p>
@@ -33519,7 +33529,7 @@
                 <a:cs typeface="Calibri"/>
                 <a:sym typeface="Calibri"/>
               </a:rPr>
-              <a:t>4–6 張機制卡，說明觸發條件、特效規則、連鎖機制</a:t>
+              <a:t>localhost 環境直接 POST，非 localhost 複製 JSON 到剪貼簿</a:t>
             </a:r>
             <a:endParaRPr sz="1100"/>
           </a:p>
@@ -33672,7 +33682,7 @@
                 <a:cs typeface="Calibri"/>
                 <a:sym typeface="Calibri"/>
               </a:rPr>
-              <a:t>遊戲流程圖</a:t>
+              <a:t>apply_corrections.py</a:t>
             </a:r>
             <a:endParaRPr sz="1100"/>
           </a:p>
@@ -33722,7 +33732,7 @@
                 <a:cs typeface="Calibri"/>
                 <a:sym typeface="Calibri"/>
               </a:rPr>
-              <a:t>主遊戲 + 免費旋轉雙列橫向流程，各節點附截圖縮圖</a:t>
+              <a:t>移動截圖並更新 classification_result.csv</a:t>
             </a:r>
             <a:endParaRPr sz="1100"/>
           </a:p>
@@ -34012,7 +34022,7 @@
                 <a:cs typeface="Calibri"/>
                 <a:sym typeface="Calibri"/>
               </a:rPr>
-              <a:t>Importing to Figma Desktop</a:t>
+              <a:t>Generating Competitive Analysis Report</a:t>
             </a:r>
             <a:endParaRPr sz="1100"/>
           </a:p>
@@ -34119,7 +34129,7 @@
                 <a:cs typeface="Calibri"/>
                 <a:sym typeface="Calibri"/>
               </a:rPr>
-              <a:t>4.4  Figma</a:t>
+              <a:t>4.4  Claude Skill 報告</a:t>
             </a:r>
             <a:endParaRPr sz="1100"/>
           </a:p>
@@ -34221,7 +34231,7 @@
                 <a:cs typeface="Calibri"/>
                 <a:sym typeface="Calibri"/>
               </a:rPr>
-              <a:t>執行 Figma Export</a:t>
+              <a:t>在 Claude Code 呼叫 slot-report Skill</a:t>
             </a:r>
             <a:endParaRPr sz="1100"/>
           </a:p>
@@ -34271,7 +34281,7 @@
                 <a:cs typeface="Calibri"/>
                 <a:sym typeface="Calibri"/>
               </a:rPr>
-              <a:t>在專案根目錄執行以下指令，自動生成 figma_export/ 資料夾與 manifest</a:t>
+              <a:t>分類完成後，在 Claude Code 輸入：</a:t>
             </a:r>
             <a:endParaRPr sz="1100"/>
           </a:p>
@@ -34378,7 +34388,7 @@
                 <a:cs typeface="Consolas"/>
                 <a:sym typeface="Consolas"/>
               </a:rPr>
-              <a:t>.\run_figma_export.ps1</a:t>
+              <a:t>幫我分析 project/output/GameName 這款遊戲，生成 report.html</a:t>
             </a:r>
             <a:endParaRPr sz="1100"/>
           </a:p>
@@ -34531,7 +34541,7 @@
                 <a:cs typeface="Calibri"/>
                 <a:sym typeface="Calibri"/>
               </a:rPr>
-              <a:t>匯入 Plugin Manifest</a:t>
+              <a:t>報告三大段落</a:t>
             </a:r>
             <a:endParaRPr sz="1100"/>
           </a:p>
@@ -34581,7 +34591,7 @@
                 <a:cs typeface="Calibri"/>
                 <a:sym typeface="Calibri"/>
               </a:rPr>
-              <a:t>開啟 Figma Desktop → Plugins &gt; Development &gt; Import plugin from manifest</a:t>
+              <a:t>📊 符號賠率表：特殊符號、主力符號、低值符號（附圖片與賠率）</a:t>
             </a:r>
             <a:endParaRPr sz="1100"/>
           </a:p>
@@ -34688,7 +34698,7 @@
                 <a:cs typeface="Consolas"/>
                 <a:sym typeface="Consolas"/>
               </a:rPr>
-              <a:t>figma_tools\figma_plugin\manifest.json</a:t>
+              <a:t>🃏 玩法機制：4–6 張機制卡，觸發條件、特效規則、連鎖機制</a:t>
             </a:r>
             <a:endParaRPr sz="1100"/>
           </a:p>
@@ -34841,7 +34851,7 @@
                 <a:cs typeface="Calibri"/>
                 <a:sym typeface="Calibri"/>
               </a:rPr>
-              <a:t>執行 Slot Research Board Importer</a:t>
+              <a:t>同步到 CCMS 瀏覽器</a:t>
             </a:r>
             <a:endParaRPr sz="1100"/>
           </a:p>
@@ -34891,7 +34901,7 @@
                 <a:cs typeface="Calibri"/>
                 <a:sym typeface="Calibri"/>
               </a:rPr>
-              <a:t>在 Figma 中執行 Plugin，選擇 figma_export/ 資料夾路徑</a:t>
+              <a:t>🗺 流程圖：主遊戲 + 免費旋轉雙列橫向流程，各節點附截圖縮圖</a:t>
             </a:r>
             <a:endParaRPr sz="1100"/>
           </a:p>
@@ -35094,7 +35104,7 @@
                 <a:cs typeface="Calibri"/>
                 <a:sym typeface="Calibri"/>
               </a:rPr>
-              <a:t>Plugin 自動建立分類截圖板，依 Loading / Basegame / Feature / BigWin 等分組排列</a:t>
+              <a:t>sync-html-to-ccms skill 同步報告至 CCMS Server，團隊直接用瀏覽器開啟，無需翻網路磁碟</a:t>
             </a:r>
             <a:endParaRPr sz="1100"/>
           </a:p>
@@ -35146,7 +35156,7 @@
                 <a:cs typeface="Calibri"/>
                 <a:sym typeface="Calibri"/>
               </a:rPr>
-              <a:t>目前Figma會匯入本地project 內所有專案</a:t>
+              <a:t/>
             </a:r>
             <a:endParaRPr sz="800">
               <a:solidFill>

</xml_diff>

<commit_message>
docs: 修正 PPTX 中 perf/cpu-optimize-ocr 分支殘留
Slide 6：
  - 說明文字改為「git clone，再執行 python setup.py 一鍵建立環境」
  - 程式碼區塊移除 git checkout，pip install 改為 python setup.py

Slide 10：
  - git pull 指令改為 git pull origin main
  - 分支名稱標注改為 main

Co-Authored-By: Claude Sonnet 4.6 <noreply@anthropic.com>
</commit_message>
<xml_diff>
--- a/docs/slot_classifier_share.pptx
+++ b/docs/slot_classifier_share.pptx
@@ -17192,7 +17192,6 @@
                 <a:sym typeface="Consolas"/>
               </a:rPr>
               <a:t>git fetch origin
-git checkout perf/cpu-optimize-ocr
 git pull</a:t>
             </a:r>
             <a:endParaRPr sz="1100"/>
@@ -17346,7 +17345,7 @@
                 <a:cs typeface="Calibri"/>
                 <a:sym typeface="Calibri"/>
               </a:rPr>
-              <a:t>perf/cpu-optimize-ocr</a:t>
+              <a:t>main</a:t>
             </a:r>
             <a:endParaRPr sz="1100"/>
           </a:p>
@@ -28304,7 +28303,7 @@
                 <a:cs typeface="Calibri"/>
                 <a:sym typeface="Calibri"/>
               </a:rPr>
-              <a:t>git clone + checkout perf/cpu-optimize-ocr，再建立 .venv 安裝套件</a:t>
+              <a:t>git clone，再執行 python setup.py 一鍵建立環境</a:t>
             </a:r>
             <a:endParaRPr sz="1100"/>
           </a:p>
@@ -28412,8 +28411,7 @@
                 <a:sym typeface="Consolas"/>
               </a:rPr>
               <a:t>git clone https://github.com/Ashley860511/slot-classifier.git
-git checkout perf/cpu-optimize-ocr
-pip install -r requirements.txt</a:t>
+python setup.py</a:t>
             </a:r>
             <a:endParaRPr sz="1100"/>
           </a:p>

</xml_diff>